<commit_message>
PRE: renumber figures in order of first mention + fix ROC A/θ inconsistency
Figure renumbering (sequential by first citation):
- Old Fig. 5 (optimal ρ*) → new Fig. 3 (first cited Sec II.D)
- Old Fig. 3 (detection probability) → new Fig. 4 (first cited Sec III.B)
- Old Fig. 4 (ROC) → new Fig. 5 (first cited Sec III.B)
- Old Fig. 7 (mutual information) → new Fig. 6 (first cited Sec III.D)
- Old Fig. 6 (DVS application) → new Fig. 7 (first cited Sec IV.D)

ROC fix: changed A/θ from 0.5 to 0.4 to match the detection probability
figure discussed in the same paragraph.

Updated: sr_simulation.py, create_manuscript.py, create_pptx.py
Regenerated: all 7 figures, manuscript_pre.docx, figures.pptx, cover_letter_pre.docx
Co-Authored-By: Tatsuki Onishi <bougtoir@gmail.com>
</commit_message>
<xml_diff>
--- a/sr_ancova_framework/pre_submission/figures.pptx
+++ b/sr_ancova_framework/pre_submission/figures.pptx
@@ -3335,7 +3335,7 @@
       </p:sp>
       <p:pic>
         <p:nvPicPr>
-          <p:cNvPr id="3" name="Picture 2" descr="fig3_detection_probability.png"/>
+          <p:cNvPr id="3" name="Picture 2" descr="fig3_optimal_rho.png"/>
           <p:cNvPicPr>
             <a:picLocks noChangeAspect="1"/>
           </p:cNvPicPr>
@@ -3349,8 +3349,8 @@
         </p:blipFill>
         <p:spPr>
           <a:xfrm>
-            <a:off x="781290" y="822960"/>
-            <a:ext cx="10629114" cy="4572000"/>
+            <a:off x="746159" y="822960"/>
+            <a:ext cx="10699376" cy="4572000"/>
           </a:xfrm>
           <a:prstGeom prst="rect">
             <a:avLst/>
@@ -3383,7 +3383,7 @@
               <a:defRPr sz="1200"/>
             </a:pPr>
             <a:r>
-              <a:t>Detection probability P_D and false alarm probability P_FA as functions of input noise level for different covariate model accuracies ρ. Higher ρ suppresses both P_D and P_FA by reducing effective noise; the net effect on detection performance depends on the operating regime.</a:t>
+              <a:t>Optimal noise model accuracy ρ* and the corresponding SNR improvement. (a) When σ &lt; θ (SR regime, yellow shading), ρ* = 0: any noise removal degrades performance. When σ &gt; θ (excess noise regime, blue shading), ρ* increases to bring effective noise to the SR optimum. (b) SNR improvement at optimal ρ* grows exponentially with input noise.</a:t>
             </a:r>
           </a:p>
         </p:txBody>
@@ -3439,7 +3439,7 @@
       </p:sp>
       <p:pic>
         <p:nvPicPr>
-          <p:cNvPr id="3" name="Picture 2" descr="fig4_roc_comparison.png"/>
+          <p:cNvPr id="3" name="Picture 2" descr="fig4_detection_probability.png"/>
           <p:cNvPicPr>
             <a:picLocks noChangeAspect="1"/>
           </p:cNvPicPr>
@@ -3453,8 +3453,8 @@
         </p:blipFill>
         <p:spPr>
           <a:xfrm>
-            <a:off x="3866509" y="822960"/>
-            <a:ext cx="4458676" cy="4572000"/>
+            <a:off x="781290" y="822960"/>
+            <a:ext cx="10629114" cy="4572000"/>
           </a:xfrm>
           <a:prstGeom prst="rect">
             <a:avLst/>
@@ -3487,7 +3487,7 @@
               <a:defRPr sz="1200"/>
             </a:pPr>
             <a:r>
-              <a:t>ROC curves at fixed input noise σ_n/θ = 1.5 (excess noise regime) for different covariate adjustment levels. In this regime, higher ρ improves the ROC curve, confirming that covariate adjustment is beneficial when the system operates above the SR optimum.</a:t>
+              <a:t>Detection probability P_D and false alarm probability P_FA as functions of input noise level for different covariate model accuracies ρ. Higher ρ suppresses both P_D and P_FA by reducing effective noise; the net effect on detection performance depends on the operating regime.</a:t>
             </a:r>
           </a:p>
         </p:txBody>
@@ -3543,7 +3543,7 @@
       </p:sp>
       <p:pic>
         <p:nvPicPr>
-          <p:cNvPr id="3" name="Picture 2" descr="fig5_optimal_rho.png"/>
+          <p:cNvPr id="3" name="Picture 2" descr="fig5_roc_comparison.png"/>
           <p:cNvPicPr>
             <a:picLocks noChangeAspect="1"/>
           </p:cNvPicPr>
@@ -3557,8 +3557,8 @@
         </p:blipFill>
         <p:spPr>
           <a:xfrm>
-            <a:off x="746159" y="822960"/>
-            <a:ext cx="10699376" cy="4572000"/>
+            <a:off x="3866509" y="822960"/>
+            <a:ext cx="4458676" cy="4572000"/>
           </a:xfrm>
           <a:prstGeom prst="rect">
             <a:avLst/>
@@ -3591,7 +3591,7 @@
               <a:defRPr sz="1200"/>
             </a:pPr>
             <a:r>
-              <a:t>Optimal noise model accuracy ρ* and the corresponding SNR improvement. (a) When σ &lt; θ (SR regime, yellow shading), ρ* = 0: any noise removal degrades performance. When σ &gt; θ (excess noise regime, blue shading), ρ* increases to bring effective noise to the SR optimum. (b) SNR improvement at optimal ρ* grows exponentially with input noise.</a:t>
+              <a:t>ROC curves at fixed input noise σ_n/θ = 1.5 (excess noise regime) for different covariate adjustment levels (A/θ = 0.4). In this regime, higher ρ improves the ROC curve, confirming that covariate adjustment is beneficial when the system operates above the SR optimum.</a:t>
             </a:r>
           </a:p>
         </p:txBody>
@@ -3647,7 +3647,7 @@
       </p:sp>
       <p:pic>
         <p:nvPicPr>
-          <p:cNvPr id="3" name="Picture 2" descr="fig6_dvs_application.png"/>
+          <p:cNvPr id="3" name="Picture 2" descr="fig6_mutual_information.png"/>
           <p:cNvPicPr>
             <a:picLocks noChangeAspect="1"/>
           </p:cNvPicPr>
@@ -3661,8 +3661,8 @@
         </p:blipFill>
         <p:spPr>
           <a:xfrm>
-            <a:off x="779047" y="822960"/>
-            <a:ext cx="10633601" cy="4572000"/>
+            <a:off x="2801318" y="822960"/>
+            <a:ext cx="6589058" cy="4572000"/>
           </a:xfrm>
           <a:prstGeom prst="rect">
             <a:avLst/>
@@ -3695,7 +3695,7 @@
               <a:defRPr sz="1200"/>
             </a:pPr>
             <a:r>
-              <a:t>Application to dynamic vision sensor (DVS) astronomical observation. (a) ROC-AUC for noise classification: the Fano filter (covariate adjustment approach) achieves AUC = 0.866, far exceeding temporal filtering and neural methods. (b) NRR vs SPR trade-off: the Fano filter preserves 93.9% of signal events while removing 71.3% of noise.</a:t>
+              <a:t>Mutual information I(S; E) between the periodic signal and the event stream as a function of input noise level. Covariate adjustment (ρ = 0.8) shifts the MI peak to higher input noise, consistent with the SR curve analysis.</a:t>
             </a:r>
           </a:p>
         </p:txBody>
@@ -3751,7 +3751,7 @@
       </p:sp>
       <p:pic>
         <p:nvPicPr>
-          <p:cNvPr id="3" name="Picture 2" descr="fig7_mutual_information.png"/>
+          <p:cNvPr id="3" name="Picture 2" descr="fig7_dvs_application.png"/>
           <p:cNvPicPr>
             <a:picLocks noChangeAspect="1"/>
           </p:cNvPicPr>
@@ -3765,8 +3765,8 @@
         </p:blipFill>
         <p:spPr>
           <a:xfrm>
-            <a:off x="2801318" y="822960"/>
-            <a:ext cx="6589058" cy="4572000"/>
+            <a:off x="779047" y="822960"/>
+            <a:ext cx="10633601" cy="4572000"/>
           </a:xfrm>
           <a:prstGeom prst="rect">
             <a:avLst/>
@@ -3799,7 +3799,7 @@
               <a:defRPr sz="1200"/>
             </a:pPr>
             <a:r>
-              <a:t>Mutual information I(S; E) between the periodic signal and the event stream as a function of input noise level. Covariate adjustment (ρ = 0.8) shifts the MI peak to higher input noise, consistent with the SR curve analysis.</a:t>
+              <a:t>Application to dynamic vision sensor (DVS) astronomical observation. (a) ROC-AUC for noise classification: the Fano filter (covariate adjustment approach) achieves AUC = 0.866, far exceeding temporal filtering and neural methods. (b) NRR vs SPR trade-off: the Fano filter preserves 93.9% of signal events while removing 71.3% of noise.</a:t>
             </a:r>
           </a:p>
         </p:txBody>

</xml_diff>

<commit_message>
regenerate PRE outputs with renumbered figures on latest master
Co-Authored-By: Tatsuki Onishi <bougtoir@gmail.com>
</commit_message>
<xml_diff>
--- a/sr_ancova_framework/pre_submission/figures.pptx
+++ b/sr_ancova_framework/pre_submission/figures.pptx
@@ -3142,7 +3142,7 @@
         <p:spPr>
           <a:xfrm>
             <a:off x="609447" y="822960"/>
-            <a:ext cx="10972800" cy="3157901"/>
+            <a:ext cx="10972800" cy="3199174"/>
           </a:xfrm>
           <a:prstGeom prst="rect">
             <a:avLst/>
@@ -3157,7 +3157,7 @@
         </p:nvSpPr>
         <p:spPr>
           <a:xfrm>
-            <a:off x="457200" y="4118021"/>
+            <a:off x="457200" y="4159294"/>
             <a:ext cx="10972800" cy="1097280"/>
           </a:xfrm>
           <a:prstGeom prst="rect">

</xml_diff>